<commit_message>
innovatex-t1-groundwater: apply final-deck hostile review — deferred verdict on missing inputs (+7 tests), denominators + manifest, rain provenance relabelled and frozen, chronology corrected, deck v3 (status tags, pulse scale, ticket timing, pilot costs, prospective customer, safety/quality gates, 9:15 route), demo gauge-outage toggle, plan/Q&A/card updates, review ledger
</commit_message>
<xml_diff>
--- a/innovatex-t1-groundwater/deliverables/zonal-deck.pptx
+++ b/innovatex-t1-groundwater/deliverables/zonal-deck.pptx
@@ -19,9 +19,10 @@
     <p:sldId id="267" r:id="rId13"/>
     <p:sldId id="268" r:id="rId14"/>
     <p:sldId id="269" r:id="rId15"/>
+    <p:sldId id="270" r:id="rId16"/>
   </p:sldIdLst>
   <p:notesMasterIdLst>
-    <p:notesMasterId r:id="rId16"/>
+    <p:notesMasterId r:id="rId17"/>
   </p:notesMasterIdLst>
   <p:sldSz cx="12192000" cy="6858000"/>
   <p:notesSz cx="6858000" cy="12192000"/>
@@ -515,8 +516,8 @@
           <a:p>
             <a:r>
               <a:rPr lang="en-US" dirty="0"/>
-              <a:t>TIME 0:00–0:20 (20 s). LOGISTICS: present from your own laptop, zonal-deck.pdf first, with the demo HTML open in a second tab (offline). Cue card: presenter-card.pdf.
-SAY: "We're ‹team›. Delhi has made rainwater harvesting compulsory for 25 years and paid crores in rebates for it. Nobody can tell you whether those pits work. We built the instrument that can."</a:t>
+              <a:t>TIME 0:00–0:20 (20 s). LOGISTICS: present from your own laptop, zonal-deck.pdf first, with the demo HTML pre-opened in a second tab (offline). Cue card: presenter-card.pdf.
+SAY: "We're ‹team›. Delhi has made rainwater harvesting compulsory for 25 years and pays rebates for it. Today, checking a pit means an inspector's visit. We propose continuous, storm-by-storm evidence. We've built the software and a simulation; the field instrument is our Round-2 build."</a:t>
             </a:r>
             <a:endParaRPr lang="en-US" dirty="0"/>
           </a:p>
@@ -604,7 +605,7 @@
           <a:p>
             <a:r>
               <a:rPr lang="en-US" dirty="0"/>
-              <a:t>TIME 8:45–10:00 (75 s incl. buffer).</a:t>
+              <a:t/>
             </a:r>
             <a:endParaRPr lang="en-US" dirty="0"/>
           </a:p>
@@ -692,7 +693,7 @@
           <a:p>
             <a:r>
               <a:rPr lang="en-US" dirty="0"/>
-              <a:t/>
+              <a:t>Reproduce: eval/realdata_profile.py. Sign convention resolved heuristically per station.</a:t>
             </a:r>
             <a:endParaRPr lang="en-US" dirty="0"/>
           </a:p>
@@ -998,6 +999,94 @@
 </p:notes>
 </file>
 
+<file path=ppt/notesSlides/notesSlide15.xml><?xml version="1.0" encoding="utf-8"?>
+<p:notes xmlns:a="http://schemas.openxmlformats.org/drawingml/2006/main" xmlns:r="http://schemas.openxmlformats.org/officeDocument/2006/relationships" xmlns:p="http://schemas.openxmlformats.org/presentationml/2006/main">
+  <p:cSld>
+    <p:spTree>
+      <p:nvGrpSpPr>
+        <p:cNvPr id="1" name=""/>
+        <p:cNvGrpSpPr/>
+        <p:nvPr/>
+      </p:nvGrpSpPr>
+      <p:grpSpPr>
+        <a:xfrm>
+          <a:off x="0" y="0"/>
+          <a:ext cx="0" cy="0"/>
+          <a:chOff x="0" y="0"/>
+          <a:chExt cx="0" cy="0"/>
+        </a:xfrm>
+      </p:grpSpPr>
+      <p:sp>
+        <p:nvSpPr>
+          <p:cNvPr id="2" name="Slide Image Placeholder 1"/>
+          <p:cNvSpPr>
+            <a:spLocks noGrp="1" noRot="1" noChangeAspect="1"/>
+          </p:cNvSpPr>
+          <p:nvPr>
+            <p:ph type="sldImg"/>
+          </p:nvPr>
+        </p:nvSpPr>
+        <p:spPr/>
+      </p:sp>
+      <p:sp>
+        <p:nvSpPr>
+          <p:cNvPr id="3" name="Notes Placeholder 2"/>
+          <p:cNvSpPr>
+            <a:spLocks noGrp="1"/>
+          </p:cNvSpPr>
+          <p:nvPr>
+            <p:ph type="body" idx="1"/>
+          </p:nvPr>
+        </p:nvSpPr>
+        <p:spPr/>
+        <p:txBody>
+          <a:bodyPr/>
+          <a:lstStyle/>
+          <a:p>
+            <a:r>
+              <a:rPr lang="en-US" dirty="0"/>
+              <a:t/>
+            </a:r>
+            <a:endParaRPr lang="en-US" dirty="0"/>
+          </a:p>
+        </p:txBody>
+      </p:sp>
+      <p:sp>
+        <p:nvSpPr>
+          <p:cNvPr id="4" name="Slide Number Placeholder 3"/>
+          <p:cNvSpPr>
+            <a:spLocks noGrp="1"/>
+          </p:cNvSpPr>
+          <p:nvPr>
+            <p:ph type="sldNum" sz="quarter" idx="10"/>
+          </p:nvPr>
+        </p:nvSpPr>
+        <p:spPr/>
+        <p:txBody>
+          <a:bodyPr/>
+          <a:lstStyle/>
+          <a:p>
+            <a:fld id="{F7021451-1387-4CA6-816F-3879F97B5CBC}" type="slidenum">
+              <a:rPr lang="en-US"/>
+              <a:t>15</a:t>
+            </a:fld>
+            <a:endParaRPr lang="en-US"/>
+          </a:p>
+        </p:txBody>
+      </p:sp>
+    </p:spTree>
+    <p:extLst>
+      <p:ext uri="{BB962C8B-B14F-4D97-AF65-F5344CB8AC3E}">
+        <p14:creationId xmlns:p14="http://schemas.microsoft.com/office/powerpoint/2010/main" val="1024086991"/>
+      </p:ext>
+    </p:extLst>
+  </p:cSld>
+  <p:clrMapOvr>
+    <a:masterClrMapping/>
+  </p:clrMapOvr>
+</p:notes>
+</file>
+
 <file path=ppt/notesSlides/notesSlide2.xml><?xml version="1.0" encoding="utf-8"?>
 <p:notes xmlns:a="http://schemas.openxmlformats.org/drawingml/2006/main" xmlns:r="http://schemas.openxmlformats.org/officeDocument/2006/relationships" xmlns:p="http://schemas.openxmlformats.org/presentationml/2006/main">
   <p:cSld>
@@ -1045,9 +1134,9 @@
             <a:r>
               <a:rPr lang="en-US" dirty="0"/>
               <a:t>TIME 0:20–1:40 (80 s).
-SAY: "The rule is 25 years old. The rebate is real money. Checking it today means a person visiting a pit, and the plan is self-declaration."
-LINE TO LAND: "The verification system doesn't exist yet. We're bidding to be it."
-DON'T SAY "never checked" or "self-certification is the rule". HT says it's planned.</a:t>
+SAY: "The rule is 25 years old and the rebate is real money. Verification today is an inspection visit plus a renewal, and the plan adds owner self-declaration."
+LINE TO LAND: "Nothing measures a pit storm by storm. That's the layer we propose, alongside inspection, not instead of it."
+DON'T SAY "never checked" or "self-certification is the rule". It's planned.</a:t>
             </a:r>
             <a:endParaRPr lang="en-US" dirty="0"/>
           </a:p>
@@ -1136,7 +1225,7 @@
             <a:r>
               <a:rPr lang="en-US" dirty="0"/>
               <a:t>TIME 1:40–2:30 (50 s).
-SAY: "Not 'Delhi is running dry'. CGWB 2025 says 92 %, and 10 tehsils are still over-exploited. The city is spending on recharge right now. Our job: make that 733-million-litre estimate auditable, one structure at a time."</a:t>
+SAY: "Not 'Delhi is running dry'. CGWB 2025 says 92 %, with 10 tehsils still over-exploited. The city is spending on recharge structures; we want each one to report how it performs after every storm."</a:t>
             </a:r>
             <a:endParaRPr lang="en-US" dirty="0"/>
           </a:p>
@@ -1224,8 +1313,9 @@
           <a:p>
             <a:r>
               <a:rPr lang="en-US" dirty="0"/>
-              <a:t>TIME 2:30–3:15 (45 s). Reproduce: eval/realdata_profile.py
-SAY: "This is our code on public data. The network that should show the aquifer responding is mostly stale or zero. So we QC it before we believe it. And where it's clean, the monsoon visibly recharges the aquifer: worth getting right."</a:t>
+              <a:t>TIME 2:30–4:00 (90 s).
+SAY: "We don't claim aquifer recharge. We measure how fast a pit drains after each storm, and estimate how much it took in, using a model we calibrate once with a metered fill."
+"If data are missing, it says 'deferred'. It never guesses." (Implemented and unit-tested: components/recharge_verifier/test_verifier.py.)</a:t>
             </a:r>
             <a:endParaRPr lang="en-US" dirty="0"/>
           </a:p>
@@ -1313,9 +1403,10 @@
           <a:p>
             <a:r>
               <a:rPr lang="en-US" dirty="0"/>
-              <a:t>TIME 3:15–4:45 (90 s).
-SAY: "We don't claim aquifer recharge. We measure what the pit does with the water it gets: how fast it drains, and roughly how much soaked in, with an honest band."
-POINT at the four verdicts. "Implausible" is how we catch a bucket poured to fake a storm.</a:t>
+              <a:t>TIME 4:00–5:15 (75 s). The demo tab is PRE-OPENED; press space. ~45 s at 1×.
+SAY (left panel): "Real data: Delhi's own groundwater monitors. 185 telemetric stations; only 46 reported this year (the latest public reading is 4 June); a quarter of all readings are exactly zero."
+SAY (right): "A simulated pit on Delhi's 2025 monsoon rain. Each event gets a verdict when it closes. Here's a large pulse the rain can't explain: random inspection, not a penalty. At the end, drain rate below half: a maintenance ticket."
+FALLBACK: this slide's image.</a:t>
             </a:r>
             <a:endParaRPr lang="en-US" dirty="0"/>
           </a:p>
@@ -1403,10 +1494,10 @@
           <a:p>
             <a:r>
               <a:rPr lang="en-US" dirty="0"/>
-              <a:t>TIME 4:45–6:00 (75 s).
-DO: open deliverables/demo/jalsakshi-demo.html (works offline), press space, let it run ~45 s, talk over the tickets.
-FALLBACK: this slide's screenshot (same demo, end of season).
-SAY: "Everything you see in the pit is simulated, and labelled so. The rain is Delhi's real 2025 monsoon."</a:t>
+              <a:t>TIME 5:15–6:15 (60 s).
+SAY: "Lead with the hard number: 13 percent on the stress test, 14.5 with a realistic probe. Three percent only happens when our simulator and verifier share the physics, so we don't sell that. Clogging calls are still noisy, with dev precision 0.4. That's why the blind drum tests come first."
+IF ASKED: five candidate fixes were rejected by a written keep rule (four helped one test but hurt another; one didn't help enough).
+Ledger and denominators: components/recharge_verifier/autoresearch/results.tsv, eval/results/manifest.json</a:t>
             </a:r>
             <a:endParaRPr lang="en-US" dirty="0"/>
           </a:p>
@@ -1494,9 +1585,7 @@
           <a:p>
             <a:r>
               <a:rPr lang="en-US" dirty="0"/>
-              <a:t>TIME 6:00–7:00 (60 s).
-SAY: "Lead with the hard number: 13 percent on the stress test, 14.5 with a realistic probe. Three percent only happens when our simulator and verifier agree on the physics, so we don't sell that. The real number comes from a blind weighed-water drum test in November."
-Ledger: components/recharge_verifier/autoresearch/results.tsv</a:t>
+              <a:t>TIME 6:15–7:00 (45 s). Probe datasheet: farnell.com/datasheets/3708809.pdf. (A) pit geometry 1.5 × 1.5 m is an assumption.</a:t>
             </a:r>
             <a:endParaRPr lang="en-US" dirty="0"/>
           </a:p>
@@ -1584,7 +1673,7 @@
           <a:p>
             <a:r>
               <a:rPr lang="en-US" dirty="0"/>
-              <a:t>TIME 7:00–7:45 (45 s).</a:t>
+              <a:t>TIME 7:00–8:00 (60 s). DON'T call ₹204 cr our market. DON'T say "first buyer".</a:t>
             </a:r>
             <a:endParaRPr lang="en-US" dirty="0"/>
           </a:p>
@@ -1672,8 +1761,7 @@
           <a:p>
             <a:r>
               <a:rPr lang="en-US" dirty="0"/>
-              <a:t>TIME 7:45–8:45 (60 s).
-DON'T claim volume pricing (not quoted). DON'T say households will rush to buy it.</a:t>
+              <a:t>TIME 8:00–9:15 (75 s). RESERVE 9:15–10:00 for handoff and questions.</a:t>
             </a:r>
             <a:endParaRPr lang="en-US" dirty="0"/>
           </a:p>
@@ -2220,6 +2308,45 @@
 <file path=ppt/slides/slide14.xml><?xml version="1.0" encoding="utf-8"?>
 <p:sld xmlns:a="http://schemas.openxmlformats.org/drawingml/2006/main" xmlns:r="http://schemas.openxmlformats.org/officeDocument/2006/relationships" xmlns:p="http://schemas.openxmlformats.org/presentationml/2006/main">
   <p:cSld name="Slide 14">
+    <p:bg>
+      <p:bgPr>
+        <a:blipFill dpi="0" rotWithShape="1">
+          <a:blip r:embed="rId1">
+            <a:lum/>
+          </a:blip>
+          <a:srcRect/>
+          <a:stretch>
+            <a:fillRect/>
+          </a:stretch>
+        </a:blipFill>
+        <a:effectLst/>
+      </p:bgPr>
+    </p:bg>
+    <p:spTree>
+      <p:nvGrpSpPr>
+        <p:cNvPr id="1" name=""/>
+        <p:cNvGrpSpPr/>
+        <p:nvPr/>
+      </p:nvGrpSpPr>
+      <p:grpSpPr>
+        <a:xfrm>
+          <a:off x="0" y="0"/>
+          <a:ext cx="0" cy="0"/>
+          <a:chOff x="0" y="0"/>
+          <a:chExt cx="0" cy="0"/>
+        </a:xfrm>
+      </p:grpSpPr>
+    </p:spTree>
+  </p:cSld>
+  <p:clrMapOvr>
+    <a:masterClrMapping/>
+  </p:clrMapOvr>
+</p:sld>
+</file>
+
+<file path=ppt/slides/slide15.xml><?xml version="1.0" encoding="utf-8"?>
+<p:sld xmlns:a="http://schemas.openxmlformats.org/drawingml/2006/main" xmlns:r="http://schemas.openxmlformats.org/officeDocument/2006/relationships" xmlns:p="http://schemas.openxmlformats.org/presentationml/2006/main">
+  <p:cSld name="Slide 15">
     <p:bg>
       <p:bgPr>
         <a:blipFill dpi="0" rotWithShape="1">

</xml_diff>